<commit_message>
Timing wording in notebook, README, memo and slides
</commit_message>
<xml_diff>
--- a/docs/slides.pptx
+++ b/docs/slides.pptx
@@ -2256,7 +2256,7 @@
           <a:p>
             <a:r>
               <a:rPr lang="en-US" dirty="0"/>
-              <a:t>Tanay (40 s): With k and the scoring fixed, the test set was used once. 40.9% of test customers had one of their next new purchases in their top 10, against 26.5% for best sellers. The product page box uses cosine similarity of the product factors, and the example shows it groups hanging-heart decorations together. The whole nightly job takes about 1.5 seconds.</a:t>
+              <a:t>Tanay (40 s): With k and the scoring fixed, the test set was used once. 40.9% of test customers had one of their next new purchases in their top 10, against 26.5% for best sellers. The product page box uses cosine similarity of the product factors, and the example shows it groups hanging-heart decorations together. The whole nightly job takes about a second.</a:t>
             </a:r>
             <a:endParaRPr lang="en-US" dirty="0"/>
           </a:p>
@@ -3608,7 +3608,7 @@
                 <a:ea typeface="Cambria" pitchFamily="34" charset="-122"/>
                 <a:cs typeface="Cambria" pitchFamily="34" charset="-120"/>
               </a:rPr>
-              <a:t>1.5 s</a:t>
+              <a:t>~1 s</a:t>
             </a:r>
             <a:endParaRPr lang="en-US" sz="4800" dirty="0"/>
           </a:p>
@@ -6263,7 +6263,7 @@
                             <a:schemeClr val="tx1"/>
                           </a:solidFill>
                         </a:rPr>
-                        <a:t>0.37 s</a:t>
+                        <a:t>0.30 s</a:t>
                       </a:r>
                       <a:endParaRPr lang="en-US" sz="1400" dirty="0"/>
                     </a:p>
@@ -6324,7 +6324,7 @@
                             <a:schemeClr val="tx1"/>
                           </a:solidFill>
                         </a:rPr>
-                        <a:t>0.29 s</a:t>
+                        <a:t>0.21 s</a:t>
                       </a:r>
                       <a:endParaRPr lang="en-US" sz="1400" dirty="0"/>
                     </a:p>

</xml_diff>